<commit_message>
docs(diagram): the slide version of the operating model is an overview, not the document
It was the reference diagram at a wider aspect ratio, which meant five bands,
nineteen boxes, a paragraph in each, an article list on every line, bilingual
subtitles and its own title block on a slide that already had a title. Legible
and unreadable at the same time.

Reduced to the three questions a room can hold while somebody talks over it: who
holds each layer, what is on it, and which layer is actually open. Boxes become
chips of two or three words, the per-box paragraphs go, the article lists
collapse to one line per band, and the service map folds into the operating
company's own row because on a slide it was a second reading of the same thing.
Four bands instead of five, and the type roughly doubles.

The 1.3:1 reference version is untouched and still carries the detail. It is
what the issue embeds and what a reader with their own pace should get.
</commit_message>
<xml_diff>
--- a/docs/demos/spain-ehds-5-slides.pptx
+++ b/docs/demos/spain-ehds-5-slides.pptx
@@ -5138,7 +5138,7 @@
                 </a:solidFill>
                 <a:latin typeface="Calibri"/>
               </a:rPr>
-              <a:t>The Catena-X operating model, re-cut for Regulation (EU) 2025/327. Two of the three layers are already law.</a:t>
+              <a:t>The Catena-X operating model, re-cut for Regulation (EU) 2025/327. One of the four layers is open.</a:t>
             </a:r>
           </a:p>
         </p:txBody>
@@ -5198,8 +5198,8 @@
         </p:blipFill>
         <p:spPr>
           <a:xfrm>
-            <a:off x="548640" y="1371600"/>
-            <a:ext cx="11091672" cy="4754880"/>
+            <a:off x="548640" y="1783080"/>
+            <a:ext cx="11091672" cy="4069080"/>
           </a:xfrm>
           <a:prstGeom prst="rect">
             <a:avLst/>

</xml_diff>

<commit_message>
docs(diagram): cut the slide overview to three tiers and one question
Still too much. Chips are shorter than paragraphs but fifteen of them across
four bands is still a page to read, and a slide is not read, it is glanced at
while somebody talks.

So: three tiers, about forty words, answering one question. European Union,
closed by law. Member State, cannot be delegated. The Operating Company, open.
The third is drawn larger and warmer than the other two because it is the one
the audience is being asked to think about, and everything it runs fits on one
line under it.

Article numbers, the service map, the five functions and the Catena-X role
mapping are gone from the slide. They were never lost: ehds-operating-model.svg
is the reference version and docs/ehds-operating-company.md is the argument, and
the slide now points at the latter instead of trying to be it.

The SVG went from 21 KB to 3 KB, which is a fair proxy for the problem.
</commit_message>
<xml_diff>
--- a/docs/demos/spain-ehds-5-slides.pptx
+++ b/docs/demos/spain-ehds-5-slides.pptx
@@ -5138,7 +5138,7 @@
                 </a:solidFill>
                 <a:latin typeface="Calibri"/>
               </a:rPr>
-              <a:t>The Catena-X operating model, re-cut for Regulation (EU) 2025/327. One of the four layers is open.</a:t>
+              <a:t>The Catena-X operating model, re-cut for Regulation (EU) 2025/327. One of the three layers is open.</a:t>
             </a:r>
           </a:p>
         </p:txBody>
@@ -5198,8 +5198,8 @@
         </p:blipFill>
         <p:spPr>
           <a:xfrm>
-            <a:off x="548640" y="1783080"/>
-            <a:ext cx="11091672" cy="4069080"/>
+            <a:off x="548640" y="2039112"/>
+            <a:ext cx="11091672" cy="3602736"/>
           </a:xfrm>
           <a:prstGeom prst="rect">
             <a:avLst/>

</xml_diff>